<commit_message>
Presentación: corregir eje x del gráfico de tasas y sumar liberación de tasas, salida del cepo y efecto electoral 2025
Co-Authored-By: Claude Opus 5.5 <noreply@anthropic.com>
Claude-Session: https://claude.ai/code/session_01LjZCUeZeukTqwmHG81QxgV
</commit_message>
<xml_diff>
--- a/presentaciones/crisis_fundar_mejorada.pptx
+++ b/presentaciones/crisis_fundar_mejorada.pptx
@@ -114,29 +114,29 @@
   <p:extLst>
     <p:ext uri="{521415D9-36F7-43E2-AB2F-B90AF26B5E84}">
       <p14:sectionLst xmlns:p14="http://schemas.microsoft.com/office/powerpoint/2010/main">
-        <p14:section name="Portada" id="{58076b22-82d4-d46a-0d83-f6361e2a8d32}">
+        <p14:section name="Portada" id="{f4540468-2e92-7f6d-c0c6-b270b9cc4590}">
           <p14:sldIdLst>
             <p14:sldId id="256"/>
           </p14:sldIdLst>
         </p14:section>
-        <p14:section name="Resumen" id="{7c84f610-955a-2699-d0ab-7b234e33d7a5}">
+        <p14:section name="Resumen" id="{eb210b88-5c41-1ef1-102b-18eb37e10fc4}">
           <p14:sldIdLst>
             <p14:sldId id="257"/>
           </p14:sldIdLst>
         </p14:section>
-        <p14:section name="Diagnóstico" id="{5f86e644-0df8-9d34-3a62-269cc8cc36cf}">
+        <p14:section name="Diagnóstico" id="{4d8a5886-758f-d8e9-4364-ca4cecc0cadc}">
           <p14:sldIdLst>
             <p14:sldId id="258"/>
             <p14:sldId id="259"/>
             <p14:sldId id="260"/>
           </p14:sldIdLst>
         </p14:section>
-        <p14:section name="Mora" id="{55b02fdb-6956-8366-c0ee-caa5bdcea89c}">
+        <p14:section name="Mora" id="{21dc7088-b180-cba9-647c-8b38dc56d9ff}">
           <p14:sldIdLst>
             <p14:sldId id="261"/>
           </p14:sldIdLst>
         </p14:section>
-        <p14:section name="Propuestas" id="{d81d9ebc-ff4d-e84b-a545-bcfe078b612a}">
+        <p14:section name="Propuestas" id="{8f4d3d8c-9c1b-0821-a625-bca0cade4fdc}">
           <p14:sldIdLst>
             <p14:sldId id="262"/>
             <p14:sldId id="263"/>
@@ -524,10 +524,10 @@
           <c:layoutTarget val="inner"/>
           <c:xMode val="edge"/>
           <c:yMode val="edge"/>
-          <c:x val="0.085"/>
-          <c:y val="0.14"/>
-          <c:w val="0.895"/>
-          <c:h val="0.76"/>
+          <c:x val="0.09"/>
+          <c:y val="0.1"/>
+          <c:w val="0.89"/>
+          <c:h val="0.8"/>
         </c:manualLayout>
       </c:layout>
       <c:lineChart>
@@ -3164,7 +3164,7 @@
         <c:scaling>
           <c:orientation val="minMax"/>
         </c:scaling>
-        <c:delete val="0"/>
+        <c:delete val="1"/>
         <c:axPos val="b"/>
         <c:numFmt formatCode="General" sourceLinked="1"/>
         <c:majorTickMark val="none"/>
@@ -4649,7 +4649,7 @@
           <a:p>
             <a:r>
               <a:rPr lang="en-US" dirty="0"/>
-              <a:t>El quiebre es julio de 2025: con el fin de las LEFIs la BADLAR nominal pasó de 32% a casi 60% en agosto. En términos reales la tasa llegó a casi 40% en septiembre y recién se normalizó tras el swap con EE.UU.</a:t>
+              <a:t>En 2025 el Gobierno liberó las tasas. Con el acuerdo con el FMI salió el cepo (abril) y con el fin de las LEFIs (julio) el BCRA dejó de fijar una tasa de referencia: la BADLAR nominal pasó de 32% a casi 60% en agosto. La incertidumbre electoral (bonaerenses en septiembre, legislativas en octubre) llevó la tasa real a casi 40%; recién bajó con el swap con EE.UU. y después de las legislativas.</a:t>
             </a:r>
             <a:endParaRPr lang="en-US" dirty="0"/>
           </a:p>
@@ -5947,7 +5947,7 @@
                   <a:schemeClr val="tx2"/>
                 </a:solidFill>
               </a:rPr>
-              <a:t>02  Crédito</a:t>
+              <a:t>Crédito</a:t>
             </a:r>
             <a:endParaRPr lang="en-US" sz="1100" dirty="0"/>
           </a:p>
@@ -6079,7 +6079,7 @@
                   <a:schemeClr val="tx2"/>
                 </a:solidFill>
               </a:rPr>
-              <a:t>03  Tasas</a:t>
+              <a:t>Tasas</a:t>
             </a:r>
             <a:endParaRPr lang="en-US" sz="1100" dirty="0"/>
           </a:p>
@@ -6211,7 +6211,7 @@
                   <a:schemeClr val="tx2"/>
                 </a:solidFill>
               </a:rPr>
-              <a:t>04  Mora</a:t>
+              <a:t>Mora (I)</a:t>
             </a:r>
             <a:endParaRPr lang="en-US" sz="1100" dirty="0"/>
           </a:p>
@@ -6343,7 +6343,7 @@
                   <a:schemeClr val="tx2"/>
                 </a:solidFill>
               </a:rPr>
-              <a:t>04  Mora</a:t>
+              <a:t>Mora (II)</a:t>
             </a:r>
             <a:endParaRPr lang="en-US" sz="1100" dirty="0"/>
           </a:p>
@@ -6464,7 +6464,7 @@
                   <a:schemeClr val="tx1"/>
                 </a:solidFill>
               </a:rPr>
-              <a:t>el ingreso real cayó, las familias se endeudaron para sostener el consumo y la suba de tasas volvió esas deudas impagables.</a:t>
+              <a:t>el ingreso real cayó, las familias se endeudaron para sostener el consumo y, con las tasas liberadas y la incertidumbre electoral de 2025, esas deudas se volvieron impagables.</a:t>
             </a:r>
             <a:endParaRPr lang="en-US" sz="1800" dirty="0"/>
           </a:p>
@@ -7544,7 +7544,7 @@
                   <a:schemeClr val="accent1"/>
                 </a:solidFill>
               </a:rPr>
-              <a:t>03  El quiebre: julio de 2025</a:t>
+              <a:t>03  El quiebre: 2025</a:t>
             </a:r>
             <a:endParaRPr lang="en-US" sz="1300" dirty="0"/>
           </a:p>
@@ -7582,7 +7582,7 @@
                   <a:schemeClr val="tx1"/>
                 </a:solidFill>
               </a:rPr>
-              <a:t>El fin de las LEFIs disparó el costo de las deudas</a:t>
+              <a:t>Tasas libres y elecciones dispararon el costo del crédito</a:t>
             </a:r>
             <a:endParaRPr lang="en-US" sz="3000" dirty="0"/>
           </a:p>
@@ -7590,14 +7590,14 @@
       </p:sp>
       <p:sp>
         <p:nvSpPr>
-          <p:cNvPr id="4" name="Período quiebre"/>
+          <p:cNvPr id="4" name="Período tasas altas"/>
           <p:cNvSpPr/>
           <p:nvPr/>
         </p:nvSpPr>
         <p:spPr>
           <a:xfrm>
-            <a:off x="3216910" y="2293315"/>
-            <a:ext cx="1153770" cy="3266237"/>
+            <a:off x="3048742" y="2180844"/>
+            <a:ext cx="1094368" cy="3182112"/>
           </a:xfrm>
           <a:prstGeom prst="rect">
             <a:avLst/>
@@ -7615,8 +7615,8 @@
           <p:nvPr/>
         </p:nvGraphicFramePr>
         <p:xfrm>
-          <a:off x="548640" y="1691640"/>
-          <a:ext cx="7589520" cy="4297680"/>
+          <a:off x="548640" y="1783080"/>
+          <a:ext cx="7040880" cy="3977640"/>
         </p:xfrm>
         <a:graphic xmlns:a="http://schemas.openxmlformats.org/drawingml/2006/main">
           <a:graphicData uri="http://schemas.openxmlformats.org/drawingml/2006/chart">
@@ -7626,14 +7626,410 @@
       </p:graphicFrame>
       <p:sp>
         <p:nvSpPr>
-          <p:cNvPr id="6" name="Evento 1"/>
+          <p:cNvPr id="6" name="Eje x ene-25"/>
+          <p:cNvSpPr txBox="1"/>
+          <p:nvPr/>
+        </p:nvSpPr>
+        <p:spPr>
+          <a:xfrm>
+            <a:off x="824055" y="5417820"/>
+            <a:ext cx="731520" cy="228600"/>
+          </a:xfrm>
+          <a:prstGeom prst="rect">
+            <a:avLst/>
+          </a:prstGeom>
+          <a:noFill/>
+          <a:ln/>
+        </p:spPr>
+        <p:txBody>
+          <a:bodyPr wrap="square" lIns="0" tIns="0" rIns="0" bIns="0" rtlCol="0" anchor="ctr"/>
+          <a:lstStyle/>
+          <a:p>
+            <a:pPr algn="ctr" indent="0" marL="0">
+              <a:buNone/>
+            </a:pPr>
+            <a:r>
+              <a:rPr lang="en-US" sz="1100" dirty="0">
+                <a:solidFill>
+                  <a:schemeClr val="tx2"/>
+                </a:solidFill>
+              </a:rPr>
+              <a:t>ene-25</a:t>
+            </a:r>
+            <a:endParaRPr lang="en-US" sz="1100" dirty="0"/>
+          </a:p>
+        </p:txBody>
+      </p:sp>
+      <p:sp>
+        <p:nvSpPr>
+          <p:cNvPr id="7" name="Eje x mar-25"/>
+          <p:cNvSpPr txBox="1"/>
+          <p:nvPr/>
+        </p:nvSpPr>
+        <p:spPr>
+          <a:xfrm>
+            <a:off x="1453691" y="5417820"/>
+            <a:ext cx="731520" cy="228600"/>
+          </a:xfrm>
+          <a:prstGeom prst="rect">
+            <a:avLst/>
+          </a:prstGeom>
+          <a:noFill/>
+          <a:ln/>
+        </p:spPr>
+        <p:txBody>
+          <a:bodyPr wrap="square" lIns="0" tIns="0" rIns="0" bIns="0" rtlCol="0" anchor="ctr"/>
+          <a:lstStyle/>
+          <a:p>
+            <a:pPr algn="ctr" indent="0" marL="0">
+              <a:buNone/>
+            </a:pPr>
+            <a:r>
+              <a:rPr lang="en-US" sz="1100" dirty="0">
+                <a:solidFill>
+                  <a:schemeClr val="tx2"/>
+                </a:solidFill>
+              </a:rPr>
+              <a:t>mar-25</a:t>
+            </a:r>
+            <a:endParaRPr lang="en-US" sz="1100" dirty="0"/>
+          </a:p>
+        </p:txBody>
+      </p:sp>
+      <p:sp>
+        <p:nvSpPr>
+          <p:cNvPr id="8" name="Eje x may-25"/>
+          <p:cNvSpPr txBox="1"/>
+          <p:nvPr/>
+        </p:nvSpPr>
+        <p:spPr>
+          <a:xfrm>
+            <a:off x="2008371" y="5417820"/>
+            <a:ext cx="731520" cy="228600"/>
+          </a:xfrm>
+          <a:prstGeom prst="rect">
+            <a:avLst/>
+          </a:prstGeom>
+          <a:noFill/>
+          <a:ln/>
+        </p:spPr>
+        <p:txBody>
+          <a:bodyPr wrap="square" lIns="0" tIns="0" rIns="0" bIns="0" rtlCol="0" anchor="ctr"/>
+          <a:lstStyle/>
+          <a:p>
+            <a:pPr algn="ctr" indent="0" marL="0">
+              <a:buNone/>
+            </a:pPr>
+            <a:r>
+              <a:rPr lang="en-US" sz="1100" dirty="0">
+                <a:solidFill>
+                  <a:schemeClr val="tx2"/>
+                </a:solidFill>
+              </a:rPr>
+              <a:t>may-25</a:t>
+            </a:r>
+            <a:endParaRPr lang="en-US" sz="1100" dirty="0"/>
+          </a:p>
+        </p:txBody>
+      </p:sp>
+      <p:sp>
+        <p:nvSpPr>
+          <p:cNvPr id="9" name="Eje x jul-25"/>
+          <p:cNvSpPr txBox="1"/>
+          <p:nvPr/>
+        </p:nvSpPr>
+        <p:spPr>
+          <a:xfrm>
+            <a:off x="2593034" y="5417820"/>
+            <a:ext cx="731520" cy="228600"/>
+          </a:xfrm>
+          <a:prstGeom prst="rect">
+            <a:avLst/>
+          </a:prstGeom>
+          <a:noFill/>
+          <a:ln/>
+        </p:spPr>
+        <p:txBody>
+          <a:bodyPr wrap="square" lIns="0" tIns="0" rIns="0" bIns="0" rtlCol="0" anchor="ctr"/>
+          <a:lstStyle/>
+          <a:p>
+            <a:pPr algn="ctr" indent="0" marL="0">
+              <a:buNone/>
+            </a:pPr>
+            <a:r>
+              <a:rPr lang="en-US" sz="1100" dirty="0">
+                <a:solidFill>
+                  <a:schemeClr val="tx2"/>
+                </a:solidFill>
+              </a:rPr>
+              <a:t>jul-25</a:t>
+            </a:r>
+            <a:endParaRPr lang="en-US" sz="1100" dirty="0"/>
+          </a:p>
+        </p:txBody>
+      </p:sp>
+      <p:sp>
+        <p:nvSpPr>
+          <p:cNvPr id="10" name="Eje x sep-25"/>
+          <p:cNvSpPr txBox="1"/>
+          <p:nvPr/>
+        </p:nvSpPr>
+        <p:spPr>
+          <a:xfrm>
+            <a:off x="3222670" y="5417820"/>
+            <a:ext cx="731520" cy="228600"/>
+          </a:xfrm>
+          <a:prstGeom prst="rect">
+            <a:avLst/>
+          </a:prstGeom>
+          <a:noFill/>
+          <a:ln/>
+        </p:spPr>
+        <p:txBody>
+          <a:bodyPr wrap="square" lIns="0" tIns="0" rIns="0" bIns="0" rtlCol="0" anchor="ctr"/>
+          <a:lstStyle/>
+          <a:p>
+            <a:pPr algn="ctr" indent="0" marL="0">
+              <a:buNone/>
+            </a:pPr>
+            <a:r>
+              <a:rPr lang="en-US" sz="1100" dirty="0">
+                <a:solidFill>
+                  <a:schemeClr val="tx2"/>
+                </a:solidFill>
+              </a:rPr>
+              <a:t>sep-25</a:t>
+            </a:r>
+            <a:endParaRPr lang="en-US" sz="1100" dirty="0"/>
+          </a:p>
+        </p:txBody>
+      </p:sp>
+      <p:sp>
+        <p:nvSpPr>
+          <p:cNvPr id="11" name="Eje x nov-25"/>
+          <p:cNvSpPr txBox="1"/>
+          <p:nvPr/>
+        </p:nvSpPr>
+        <p:spPr>
+          <a:xfrm>
+            <a:off x="3882290" y="5417820"/>
+            <a:ext cx="731520" cy="228600"/>
+          </a:xfrm>
+          <a:prstGeom prst="rect">
+            <a:avLst/>
+          </a:prstGeom>
+          <a:noFill/>
+          <a:ln/>
+        </p:spPr>
+        <p:txBody>
+          <a:bodyPr wrap="square" lIns="0" tIns="0" rIns="0" bIns="0" rtlCol="0" anchor="ctr"/>
+          <a:lstStyle/>
+          <a:p>
+            <a:pPr algn="ctr" indent="0" marL="0">
+              <a:buNone/>
+            </a:pPr>
+            <a:r>
+              <a:rPr lang="en-US" sz="1100" dirty="0">
+                <a:solidFill>
+                  <a:schemeClr val="tx2"/>
+                </a:solidFill>
+              </a:rPr>
+              <a:t>nov-25</a:t>
+            </a:r>
+            <a:endParaRPr lang="en-US" sz="1100" dirty="0"/>
+          </a:p>
+        </p:txBody>
+      </p:sp>
+      <p:sp>
+        <p:nvSpPr>
+          <p:cNvPr id="12" name="Eje x ene-26"/>
+          <p:cNvSpPr txBox="1"/>
+          <p:nvPr/>
+        </p:nvSpPr>
+        <p:spPr>
+          <a:xfrm>
+            <a:off x="4421978" y="5417820"/>
+            <a:ext cx="731520" cy="228600"/>
+          </a:xfrm>
+          <a:prstGeom prst="rect">
+            <a:avLst/>
+          </a:prstGeom>
+          <a:noFill/>
+          <a:ln/>
+        </p:spPr>
+        <p:txBody>
+          <a:bodyPr wrap="square" lIns="0" tIns="0" rIns="0" bIns="0" rtlCol="0" anchor="ctr"/>
+          <a:lstStyle/>
+          <a:p>
+            <a:pPr algn="ctr" indent="0" marL="0">
+              <a:buNone/>
+            </a:pPr>
+            <a:r>
+              <a:rPr lang="en-US" sz="1100" dirty="0">
+                <a:solidFill>
+                  <a:schemeClr val="tx2"/>
+                </a:solidFill>
+              </a:rPr>
+              <a:t>ene-26</a:t>
+            </a:r>
+            <a:endParaRPr lang="en-US" sz="1100" dirty="0"/>
+          </a:p>
+        </p:txBody>
+      </p:sp>
+      <p:sp>
+        <p:nvSpPr>
+          <p:cNvPr id="13" name="Eje x mar-26"/>
+          <p:cNvSpPr txBox="1"/>
+          <p:nvPr/>
+        </p:nvSpPr>
+        <p:spPr>
+          <a:xfrm>
+            <a:off x="5006641" y="5417820"/>
+            <a:ext cx="731520" cy="228600"/>
+          </a:xfrm>
+          <a:prstGeom prst="rect">
+            <a:avLst/>
+          </a:prstGeom>
+          <a:noFill/>
+          <a:ln/>
+        </p:spPr>
+        <p:txBody>
+          <a:bodyPr wrap="square" lIns="0" tIns="0" rIns="0" bIns="0" rtlCol="0" anchor="ctr"/>
+          <a:lstStyle/>
+          <a:p>
+            <a:pPr algn="ctr" indent="0" marL="0">
+              <a:buNone/>
+            </a:pPr>
+            <a:r>
+              <a:rPr lang="en-US" sz="1100" dirty="0">
+                <a:solidFill>
+                  <a:schemeClr val="tx2"/>
+                </a:solidFill>
+              </a:rPr>
+              <a:t>mar-26</a:t>
+            </a:r>
+            <a:endParaRPr lang="en-US" sz="1100" dirty="0"/>
+          </a:p>
+        </p:txBody>
+      </p:sp>
+      <p:sp>
+        <p:nvSpPr>
+          <p:cNvPr id="14" name="Eje x may-26"/>
+          <p:cNvSpPr txBox="1"/>
+          <p:nvPr/>
+        </p:nvSpPr>
+        <p:spPr>
+          <a:xfrm>
+            <a:off x="5606295" y="5417820"/>
+            <a:ext cx="731520" cy="228600"/>
+          </a:xfrm>
+          <a:prstGeom prst="rect">
+            <a:avLst/>
+          </a:prstGeom>
+          <a:noFill/>
+          <a:ln/>
+        </p:spPr>
+        <p:txBody>
+          <a:bodyPr wrap="square" lIns="0" tIns="0" rIns="0" bIns="0" rtlCol="0" anchor="ctr"/>
+          <a:lstStyle/>
+          <a:p>
+            <a:pPr algn="ctr" indent="0" marL="0">
+              <a:buNone/>
+            </a:pPr>
+            <a:r>
+              <a:rPr lang="en-US" sz="1100" dirty="0">
+                <a:solidFill>
+                  <a:schemeClr val="tx2"/>
+                </a:solidFill>
+              </a:rPr>
+              <a:t>may-26</a:t>
+            </a:r>
+            <a:endParaRPr lang="en-US" sz="1100" dirty="0"/>
+          </a:p>
+        </p:txBody>
+      </p:sp>
+      <p:sp>
+        <p:nvSpPr>
+          <p:cNvPr id="15" name="Eje x jul-26"/>
+          <p:cNvSpPr txBox="1"/>
+          <p:nvPr/>
+        </p:nvSpPr>
+        <p:spPr>
+          <a:xfrm>
+            <a:off x="6205949" y="5417820"/>
+            <a:ext cx="731520" cy="228600"/>
+          </a:xfrm>
+          <a:prstGeom prst="rect">
+            <a:avLst/>
+          </a:prstGeom>
+          <a:noFill/>
+          <a:ln/>
+        </p:spPr>
+        <p:txBody>
+          <a:bodyPr wrap="square" lIns="0" tIns="0" rIns="0" bIns="0" rtlCol="0" anchor="ctr"/>
+          <a:lstStyle/>
+          <a:p>
+            <a:pPr algn="ctr" indent="0" marL="0">
+              <a:buNone/>
+            </a:pPr>
+            <a:r>
+              <a:rPr lang="en-US" sz="1100" dirty="0">
+                <a:solidFill>
+                  <a:schemeClr val="tx2"/>
+                </a:solidFill>
+              </a:rPr>
+              <a:t>jul-26</a:t>
+            </a:r>
+            <a:endParaRPr lang="en-US" sz="1100" dirty="0"/>
+          </a:p>
+        </p:txBody>
+      </p:sp>
+      <p:sp>
+        <p:nvSpPr>
+          <p:cNvPr id="16" name="Eje x sep-26"/>
+          <p:cNvSpPr txBox="1"/>
+          <p:nvPr/>
+        </p:nvSpPr>
+        <p:spPr>
+          <a:xfrm>
+            <a:off x="6820594" y="5417820"/>
+            <a:ext cx="731520" cy="228600"/>
+          </a:xfrm>
+          <a:prstGeom prst="rect">
+            <a:avLst/>
+          </a:prstGeom>
+          <a:noFill/>
+          <a:ln/>
+        </p:spPr>
+        <p:txBody>
+          <a:bodyPr wrap="square" lIns="0" tIns="0" rIns="0" bIns="0" rtlCol="0" anchor="ctr"/>
+          <a:lstStyle/>
+          <a:p>
+            <a:pPr algn="ctr" indent="0" marL="0">
+              <a:buNone/>
+            </a:pPr>
+            <a:r>
+              <a:rPr lang="en-US" sz="1100" dirty="0">
+                <a:solidFill>
+                  <a:schemeClr val="tx2"/>
+                </a:solidFill>
+              </a:rPr>
+              <a:t>sep-26</a:t>
+            </a:r>
+            <a:endParaRPr lang="en-US" sz="1100" dirty="0"/>
+          </a:p>
+        </p:txBody>
+      </p:sp>
+      <p:sp>
+        <p:nvSpPr>
+          <p:cNvPr id="17" name="Evento 1"/>
           <p:cNvSpPr/>
           <p:nvPr/>
         </p:nvSpPr>
         <p:spPr>
           <a:xfrm>
-            <a:off x="2290644" y="2293315"/>
-            <a:ext cx="0" cy="3266237"/>
+            <a:off x="2194235" y="2363724"/>
+            <a:ext cx="0" cy="2999232"/>
           </a:xfrm>
           <a:prstGeom prst="line">
             <a:avLst/>
@@ -7649,14 +8045,34 @@
       </p:sp>
       <p:sp>
         <p:nvSpPr>
-          <p:cNvPr id="7" name="Text 4"/>
+          <p:cNvPr id="18" name="Marca evento 1"/>
+          <p:cNvSpPr/>
+          <p:nvPr/>
+        </p:nvSpPr>
+        <p:spPr>
+          <a:xfrm>
+            <a:off x="2075363" y="2107692"/>
+            <a:ext cx="237744" cy="237744"/>
+          </a:xfrm>
+          <a:prstGeom prst="ellipse">
+            <a:avLst/>
+          </a:prstGeom>
+          <a:solidFill>
+            <a:schemeClr val="tx1"/>
+          </a:solidFill>
+          <a:ln/>
+        </p:spPr>
+      </p:sp>
+      <p:sp>
+        <p:nvSpPr>
+          <p:cNvPr id="19" name="Text 16"/>
           <p:cNvSpPr txBox="1"/>
           <p:nvPr/>
         </p:nvSpPr>
         <p:spPr>
           <a:xfrm>
-            <a:off x="1742004" y="1691640"/>
-            <a:ext cx="1097280" cy="565099"/>
+            <a:off x="2075363" y="2107692"/>
+            <a:ext cx="237744" cy="237744"/>
           </a:xfrm>
           <a:prstGeom prst="rect">
             <a:avLst/>
@@ -7665,48 +8081,34 @@
           <a:ln/>
         </p:spPr>
         <p:txBody>
-          <a:bodyPr wrap="square" lIns="0" tIns="0" rIns="0" bIns="0" rtlCol="0" anchor="b"/>
+          <a:bodyPr wrap="square" lIns="0" tIns="0" rIns="0" bIns="0" rtlCol="0" anchor="ctr"/>
           <a:lstStyle/>
           <a:p>
             <a:pPr algn="ctr" indent="0" marL="0">
               <a:buNone/>
             </a:pPr>
             <a:r>
-              <a:rPr lang="en-US" sz="1000" dirty="0">
-                <a:solidFill>
-                  <a:schemeClr val="tx2"/>
+              <a:rPr lang="en-US" sz="1000" b="1" dirty="0">
+                <a:solidFill>
+                  <a:schemeClr val="bg1"/>
                 </a:solidFill>
               </a:rPr>
-              <a:t>Acuerdo FMI</a:t>
+              <a:t>1</a:t>
             </a:r>
             <a:endParaRPr lang="en-US" sz="1000" dirty="0"/>
           </a:p>
-          <a:p>
-            <a:pPr algn="ctr" indent="0" marL="0">
-              <a:buNone/>
-            </a:pPr>
-            <a:r>
-              <a:rPr lang="en-US" sz="1000" dirty="0">
-                <a:solidFill>
-                  <a:schemeClr val="tx2"/>
-                </a:solidFill>
-              </a:rPr>
-              <a:t>11-abr-25</a:t>
-            </a:r>
-            <a:endParaRPr lang="en-US" sz="1000" dirty="0"/>
-          </a:p>
-        </p:txBody>
-      </p:sp>
-      <p:sp>
-        <p:nvSpPr>
-          <p:cNvPr id="8" name="Evento 2"/>
+        </p:txBody>
+      </p:sp>
+      <p:sp>
+        <p:nvSpPr>
+          <p:cNvPr id="20" name="Evento 2"/>
           <p:cNvSpPr/>
           <p:nvPr/>
         </p:nvSpPr>
         <p:spPr>
           <a:xfrm>
-            <a:off x="3216910" y="2293315"/>
-            <a:ext cx="0" cy="3266237"/>
+            <a:off x="3048742" y="2363724"/>
+            <a:ext cx="0" cy="2999232"/>
           </a:xfrm>
           <a:prstGeom prst="line">
             <a:avLst/>
@@ -7722,14 +8124,34 @@
       </p:sp>
       <p:sp>
         <p:nvSpPr>
-          <p:cNvPr id="9" name="Text 6"/>
+          <p:cNvPr id="21" name="Marca evento 2"/>
+          <p:cNvSpPr/>
+          <p:nvPr/>
+        </p:nvSpPr>
+        <p:spPr>
+          <a:xfrm>
+            <a:off x="2929870" y="2107692"/>
+            <a:ext cx="237744" cy="237744"/>
+          </a:xfrm>
+          <a:prstGeom prst="ellipse">
+            <a:avLst/>
+          </a:prstGeom>
+          <a:solidFill>
+            <a:schemeClr val="tx1"/>
+          </a:solidFill>
+          <a:ln/>
+        </p:spPr>
+      </p:sp>
+      <p:sp>
+        <p:nvSpPr>
+          <p:cNvPr id="22" name="Text 19"/>
           <p:cNvSpPr txBox="1"/>
           <p:nvPr/>
         </p:nvSpPr>
         <p:spPr>
           <a:xfrm>
-            <a:off x="2668270" y="1691640"/>
-            <a:ext cx="1097280" cy="565099"/>
+            <a:off x="2929870" y="2107692"/>
+            <a:ext cx="237744" cy="237744"/>
           </a:xfrm>
           <a:prstGeom prst="rect">
             <a:avLst/>
@@ -7738,48 +8160,34 @@
           <a:ln/>
         </p:spPr>
         <p:txBody>
-          <a:bodyPr wrap="square" lIns="0" tIns="0" rIns="0" bIns="0" rtlCol="0" anchor="b"/>
+          <a:bodyPr wrap="square" lIns="0" tIns="0" rIns="0" bIns="0" rtlCol="0" anchor="ctr"/>
           <a:lstStyle/>
           <a:p>
             <a:pPr algn="ctr" indent="0" marL="0">
               <a:buNone/>
             </a:pPr>
             <a:r>
-              <a:rPr lang="en-US" sz="1000" dirty="0">
-                <a:solidFill>
-                  <a:schemeClr val="tx2"/>
+              <a:rPr lang="en-US" sz="1000" b="1" dirty="0">
+                <a:solidFill>
+                  <a:schemeClr val="bg1"/>
                 </a:solidFill>
               </a:rPr>
-              <a:t>Fin LEFIs</a:t>
+              <a:t>2</a:t>
             </a:r>
             <a:endParaRPr lang="en-US" sz="1000" dirty="0"/>
           </a:p>
-          <a:p>
-            <a:pPr algn="ctr" indent="0" marL="0">
-              <a:buNone/>
-            </a:pPr>
-            <a:r>
-              <a:rPr lang="en-US" sz="1000" dirty="0">
-                <a:solidFill>
-                  <a:schemeClr val="tx2"/>
-                </a:solidFill>
-              </a:rPr>
-              <a:t>10-jul-25</a:t>
-            </a:r>
-            <a:endParaRPr lang="en-US" sz="1000" dirty="0"/>
-          </a:p>
-        </p:txBody>
-      </p:sp>
-      <p:sp>
-        <p:nvSpPr>
-          <p:cNvPr id="10" name="Evento 3"/>
+        </p:txBody>
+      </p:sp>
+      <p:sp>
+        <p:nvSpPr>
+          <p:cNvPr id="23" name="Evento 3"/>
           <p:cNvSpPr/>
           <p:nvPr/>
         </p:nvSpPr>
         <p:spPr>
           <a:xfrm>
-            <a:off x="4370681" y="2293315"/>
-            <a:ext cx="0" cy="3266237"/>
+            <a:off x="3663387" y="2363724"/>
+            <a:ext cx="0" cy="2999232"/>
           </a:xfrm>
           <a:prstGeom prst="line">
             <a:avLst/>
@@ -7795,14 +8203,34 @@
       </p:sp>
       <p:sp>
         <p:nvSpPr>
-          <p:cNvPr id="11" name="Text 8"/>
+          <p:cNvPr id="24" name="Marca evento 3"/>
+          <p:cNvSpPr/>
+          <p:nvPr/>
+        </p:nvSpPr>
+        <p:spPr>
+          <a:xfrm>
+            <a:off x="3544515" y="2107692"/>
+            <a:ext cx="237744" cy="237744"/>
+          </a:xfrm>
+          <a:prstGeom prst="ellipse">
+            <a:avLst/>
+          </a:prstGeom>
+          <a:solidFill>
+            <a:schemeClr val="tx1"/>
+          </a:solidFill>
+          <a:ln/>
+        </p:spPr>
+      </p:sp>
+      <p:sp>
+        <p:nvSpPr>
+          <p:cNvPr id="25" name="Text 22"/>
           <p:cNvSpPr txBox="1"/>
           <p:nvPr/>
         </p:nvSpPr>
         <p:spPr>
           <a:xfrm>
-            <a:off x="3822041" y="1691640"/>
-            <a:ext cx="1097280" cy="565099"/>
+            <a:off x="3544515" y="2107692"/>
+            <a:ext cx="237744" cy="237744"/>
           </a:xfrm>
           <a:prstGeom prst="rect">
             <a:avLst/>
@@ -7811,33 +8239,98 @@
           <a:ln/>
         </p:spPr>
         <p:txBody>
-          <a:bodyPr wrap="square" lIns="0" tIns="0" rIns="0" bIns="0" rtlCol="0" anchor="b"/>
+          <a:bodyPr wrap="square" lIns="0" tIns="0" rIns="0" bIns="0" rtlCol="0" anchor="ctr"/>
           <a:lstStyle/>
           <a:p>
             <a:pPr algn="ctr" indent="0" marL="0">
               <a:buNone/>
             </a:pPr>
             <a:r>
-              <a:rPr lang="en-US" sz="1000" dirty="0">
-                <a:solidFill>
-                  <a:schemeClr val="tx2"/>
+              <a:rPr lang="en-US" sz="1000" b="1" dirty="0">
+                <a:solidFill>
+                  <a:schemeClr val="bg1"/>
                 </a:solidFill>
               </a:rPr>
-              <a:t>Swap EE.UU.</a:t>
+              <a:t>3</a:t>
             </a:r>
             <a:endParaRPr lang="en-US" sz="1000" dirty="0"/>
           </a:p>
+        </p:txBody>
+      </p:sp>
+      <p:sp>
+        <p:nvSpPr>
+          <p:cNvPr id="26" name="Evento 4"/>
+          <p:cNvSpPr/>
+          <p:nvPr/>
+        </p:nvSpPr>
+        <p:spPr>
+          <a:xfrm>
+            <a:off x="4143110" y="2363724"/>
+            <a:ext cx="0" cy="2999232"/>
+          </a:xfrm>
+          <a:prstGeom prst="line">
+            <a:avLst/>
+          </a:prstGeom>
+          <a:noFill/>
+          <a:ln w="12700">
+            <a:solidFill>
+              <a:srgbClr val="595959"/>
+            </a:solidFill>
+            <a:prstDash val="dash"/>
+          </a:ln>
+        </p:spPr>
+      </p:sp>
+      <p:sp>
+        <p:nvSpPr>
+          <p:cNvPr id="27" name="Marca evento 4"/>
+          <p:cNvSpPr/>
+          <p:nvPr/>
+        </p:nvSpPr>
+        <p:spPr>
+          <a:xfrm>
+            <a:off x="4024238" y="2107692"/>
+            <a:ext cx="237744" cy="237744"/>
+          </a:xfrm>
+          <a:prstGeom prst="ellipse">
+            <a:avLst/>
+          </a:prstGeom>
+          <a:solidFill>
+            <a:schemeClr val="tx1"/>
+          </a:solidFill>
+          <a:ln/>
+        </p:spPr>
+      </p:sp>
+      <p:sp>
+        <p:nvSpPr>
+          <p:cNvPr id="28" name="Text 25"/>
+          <p:cNvSpPr txBox="1"/>
+          <p:nvPr/>
+        </p:nvSpPr>
+        <p:spPr>
+          <a:xfrm>
+            <a:off x="4024238" y="2107692"/>
+            <a:ext cx="237744" cy="237744"/>
+          </a:xfrm>
+          <a:prstGeom prst="rect">
+            <a:avLst/>
+          </a:prstGeom>
+          <a:noFill/>
+          <a:ln/>
+        </p:spPr>
+        <p:txBody>
+          <a:bodyPr wrap="square" lIns="0" tIns="0" rIns="0" bIns="0" rtlCol="0" anchor="ctr"/>
+          <a:lstStyle/>
           <a:p>
             <a:pPr algn="ctr" indent="0" marL="0">
               <a:buNone/>
             </a:pPr>
             <a:r>
-              <a:rPr lang="en-US" sz="1000" dirty="0">
-                <a:solidFill>
-                  <a:schemeClr val="tx2"/>
+              <a:rPr lang="en-US" sz="1000" b="1" dirty="0">
+                <a:solidFill>
+                  <a:schemeClr val="bg1"/>
                 </a:solidFill>
               </a:rPr>
-              <a:t>20-oct-25</a:t>
+              <a:t>4</a:t>
             </a:r>
             <a:endParaRPr lang="en-US" sz="1000" dirty="0"/>
           </a:p>
@@ -7845,13 +8338,13 @@
       </p:sp>
       <p:sp>
         <p:nvSpPr>
-          <p:cNvPr id="12" name="Text 9"/>
+          <p:cNvPr id="29" name="Text 26"/>
           <p:cNvSpPr txBox="1"/>
           <p:nvPr/>
         </p:nvSpPr>
         <p:spPr>
           <a:xfrm>
-            <a:off x="548640" y="1508760"/>
+            <a:off x="548640" y="1600200"/>
             <a:ext cx="5486400" cy="228600"/>
           </a:xfrm>
           <a:prstGeom prst="rect">
@@ -7881,18 +8374,18 @@
       </p:sp>
       <p:sp>
         <p:nvSpPr>
-          <p:cNvPr id="13" name="Panel lectura"/>
+          <p:cNvPr id="30" name="Panel hitos"/>
           <p:cNvSpPr/>
           <p:nvPr/>
         </p:nvSpPr>
         <p:spPr>
           <a:xfrm>
-            <a:off x="8503920" y="1828800"/>
-            <a:ext cx="3139135" cy="4023360"/>
+            <a:off x="8001000" y="1691640"/>
+            <a:ext cx="3642055" cy="4251960"/>
           </a:xfrm>
           <a:prstGeom prst="roundRect">
             <a:avLst>
-              <a:gd name="adj" fmla="val 3495"/>
+              <a:gd name="adj" fmla="val 3013"/>
             </a:avLst>
           </a:prstGeom>
           <a:solidFill>
@@ -7903,14 +8396,34 @@
       </p:sp>
       <p:sp>
         <p:nvSpPr>
-          <p:cNvPr id="14" name="Text 11"/>
+          <p:cNvPr id="31" name="Shape 28"/>
+          <p:cNvSpPr/>
+          <p:nvPr/>
+        </p:nvSpPr>
+        <p:spPr>
+          <a:xfrm>
+            <a:off x="8275320" y="1920240"/>
+            <a:ext cx="274320" cy="274320"/>
+          </a:xfrm>
+          <a:prstGeom prst="ellipse">
+            <a:avLst/>
+          </a:prstGeom>
+          <a:solidFill>
+            <a:schemeClr val="tx1"/>
+          </a:solidFill>
+          <a:ln/>
+        </p:spPr>
+      </p:sp>
+      <p:sp>
+        <p:nvSpPr>
+          <p:cNvPr id="32" name="Text 29"/>
           <p:cNvSpPr txBox="1"/>
           <p:nvPr/>
         </p:nvSpPr>
         <p:spPr>
           <a:xfrm>
-            <a:off x="8823960" y="2103120"/>
-            <a:ext cx="2499055" cy="731520"/>
+            <a:off x="8275320" y="1920240"/>
+            <a:ext cx="274320" cy="274320"/>
           </a:xfrm>
           <a:prstGeom prst="rect">
             <a:avLst/>
@@ -7919,36 +8432,34 @@
           <a:ln/>
         </p:spPr>
         <p:txBody>
-          <a:bodyPr wrap="square" lIns="0" tIns="0" rIns="0" bIns="0" rtlCol="0" anchor="ctr">
-            <a:normAutofit/>
-          </a:bodyPr>
-          <a:lstStyle/>
-          <a:p>
-            <a:pPr indent="0" marL="0">
+          <a:bodyPr wrap="square" lIns="0" tIns="0" rIns="0" bIns="0" rtlCol="0" anchor="ctr"/>
+          <a:lstStyle/>
+          <a:p>
+            <a:pPr algn="ctr" indent="0" marL="0">
               <a:buNone/>
             </a:pPr>
             <a:r>
-              <a:rPr lang="en-US" sz="3600" b="1" dirty="0">
-                <a:solidFill>
-                  <a:schemeClr val="accent5"/>
+              <a:rPr lang="en-US" sz="1100" b="1" dirty="0">
+                <a:solidFill>
+                  <a:schemeClr val="bg1"/>
                 </a:solidFill>
               </a:rPr>
-              <a:t>32% → 60%</a:t>
+              <a:t>1</a:t>
             </a:r>
-            <a:endParaRPr lang="en-US" sz="3600" dirty="0"/>
-          </a:p>
-        </p:txBody>
-      </p:sp>
-      <p:sp>
-        <p:nvSpPr>
-          <p:cNvPr id="15" name="Text 12"/>
+            <a:endParaRPr lang="en-US" sz="1100" dirty="0"/>
+          </a:p>
+        </p:txBody>
+      </p:sp>
+      <p:sp>
+        <p:nvSpPr>
+          <p:cNvPr id="33" name="Text 30"/>
           <p:cNvSpPr txBox="1"/>
           <p:nvPr/>
         </p:nvSpPr>
         <p:spPr>
           <a:xfrm>
-            <a:off x="8823960" y="2834640"/>
-            <a:ext cx="2499055" cy="731520"/>
+            <a:off x="8686800" y="1901952"/>
+            <a:ext cx="2727655" cy="896112"/>
           </a:xfrm>
           <a:prstGeom prst="rect">
             <a:avLst/>
@@ -7961,59 +8472,379 @@
           <a:lstStyle/>
           <a:p>
             <a:pPr indent="0" marL="0">
+              <a:spcAft>
+                <a:spcPts val="200"/>
+              </a:spcAft>
               <a:buNone/>
             </a:pPr>
             <a:r>
-              <a:rPr lang="en-US" sz="1500" dirty="0">
+              <a:rPr lang="en-US" sz="1200" b="1" dirty="0">
                 <a:solidFill>
                   <a:schemeClr val="tx1"/>
                 </a:solidFill>
               </a:rPr>
-              <a:t>BADLAR nominal: de 32% en julio a casi 60% en agosto de 2025</a:t>
+              <a:t>Abr-25 · Acuerdo con el FMI y salida del cepo</a:t>
             </a:r>
-            <a:endParaRPr lang="en-US" sz="1500" dirty="0"/>
-          </a:p>
-        </p:txBody>
-      </p:sp>
-      <p:sp>
-        <p:nvSpPr>
-          <p:cNvPr id="16" name="Text 13"/>
-          <p:cNvSpPr txBox="1"/>
-          <p:nvPr/>
-        </p:nvSpPr>
-        <p:spPr>
-          <a:xfrm>
-            <a:off x="8823960" y="3749040"/>
-            <a:ext cx="2499055" cy="1920240"/>
-          </a:xfrm>
-          <a:prstGeom prst="rect">
-            <a:avLst/>
-          </a:prstGeom>
-          <a:noFill/>
-          <a:ln/>
-        </p:spPr>
-        <p:txBody>
-          <a:bodyPr wrap="square" lIns="0" tIns="0" rIns="0" bIns="0" rtlCol="0" anchor="t"/>
-          <a:lstStyle/>
+            <a:endParaRPr lang="en-US" sz="1200" dirty="0"/>
+          </a:p>
           <a:p>
             <a:pPr indent="0" marL="0">
+              <a:spcAft>
+                <a:spcPts val="200"/>
+              </a:spcAft>
               <a:buNone/>
             </a:pPr>
             <a:r>
-              <a:rPr lang="en-US" sz="1400" dirty="0">
+              <a:rPr lang="en-US" sz="1200" dirty="0">
                 <a:solidFill>
                   <a:schemeClr val="tx1"/>
                 </a:solidFill>
               </a:rPr>
-              <a:t>El desarme de las LEFIs forzó a subir fuerte las tasas. En términos reales, la BADLAR pasó de valores negativos a cerca de 40% anual en septiembre: las deudas a tasa variable se volvieron impagables.</a:t>
+              <a:t>El dólar flota dentro de bandas y el BCRA pasa a un esquema de agregados monetarios.</a:t>
             </a:r>
-            <a:endParaRPr lang="en-US" sz="1400" dirty="0"/>
-          </a:p>
-        </p:txBody>
-      </p:sp>
-      <p:sp>
-        <p:nvSpPr>
-          <p:cNvPr id="17" name="Fuente"/>
+            <a:endParaRPr lang="en-US" sz="1200" dirty="0"/>
+          </a:p>
+        </p:txBody>
+      </p:sp>
+      <p:sp>
+        <p:nvSpPr>
+          <p:cNvPr id="34" name="Shape 31"/>
+          <p:cNvSpPr/>
+          <p:nvPr/>
+        </p:nvSpPr>
+        <p:spPr>
+          <a:xfrm>
+            <a:off x="8275320" y="2907792"/>
+            <a:ext cx="274320" cy="274320"/>
+          </a:xfrm>
+          <a:prstGeom prst="ellipse">
+            <a:avLst/>
+          </a:prstGeom>
+          <a:solidFill>
+            <a:schemeClr val="tx1"/>
+          </a:solidFill>
+          <a:ln/>
+        </p:spPr>
+      </p:sp>
+      <p:sp>
+        <p:nvSpPr>
+          <p:cNvPr id="35" name="Text 32"/>
+          <p:cNvSpPr txBox="1"/>
+          <p:nvPr/>
+        </p:nvSpPr>
+        <p:spPr>
+          <a:xfrm>
+            <a:off x="8275320" y="2907792"/>
+            <a:ext cx="274320" cy="274320"/>
+          </a:xfrm>
+          <a:prstGeom prst="rect">
+            <a:avLst/>
+          </a:prstGeom>
+          <a:noFill/>
+          <a:ln/>
+        </p:spPr>
+        <p:txBody>
+          <a:bodyPr wrap="square" lIns="0" tIns="0" rIns="0" bIns="0" rtlCol="0" anchor="ctr"/>
+          <a:lstStyle/>
+          <a:p>
+            <a:pPr algn="ctr" indent="0" marL="0">
+              <a:buNone/>
+            </a:pPr>
+            <a:r>
+              <a:rPr lang="en-US" sz="1100" b="1" dirty="0">
+                <a:solidFill>
+                  <a:schemeClr val="bg1"/>
+                </a:solidFill>
+              </a:rPr>
+              <a:t>2</a:t>
+            </a:r>
+            <a:endParaRPr lang="en-US" sz="1100" dirty="0"/>
+          </a:p>
+        </p:txBody>
+      </p:sp>
+      <p:sp>
+        <p:nvSpPr>
+          <p:cNvPr id="36" name="Text 33"/>
+          <p:cNvSpPr txBox="1"/>
+          <p:nvPr/>
+        </p:nvSpPr>
+        <p:spPr>
+          <a:xfrm>
+            <a:off x="8686800" y="2889504"/>
+            <a:ext cx="2727655" cy="896112"/>
+          </a:xfrm>
+          <a:prstGeom prst="rect">
+            <a:avLst/>
+          </a:prstGeom>
+          <a:noFill/>
+          <a:ln/>
+        </p:spPr>
+        <p:txBody>
+          <a:bodyPr wrap="square" lIns="0" tIns="0" rIns="0" bIns="0" rtlCol="0" anchor="t"/>
+          <a:lstStyle/>
+          <a:p>
+            <a:pPr indent="0" marL="0">
+              <a:spcAft>
+                <a:spcPts val="200"/>
+              </a:spcAft>
+              <a:buNone/>
+            </a:pPr>
+            <a:r>
+              <a:rPr lang="en-US" sz="1200" b="1" dirty="0">
+                <a:solidFill>
+                  <a:schemeClr val="tx1"/>
+                </a:solidFill>
+              </a:rPr>
+              <a:t>Jul-25 · Fin de las LEFIs</a:t>
+            </a:r>
+            <a:endParaRPr lang="en-US" sz="1200" dirty="0"/>
+          </a:p>
+          <a:p>
+            <a:pPr indent="0" marL="0">
+              <a:spcAft>
+                <a:spcPts val="200"/>
+              </a:spcAft>
+              <a:buNone/>
+            </a:pPr>
+            <a:r>
+              <a:rPr lang="en-US" sz="1200" dirty="0">
+                <a:solidFill>
+                  <a:schemeClr val="tx1"/>
+                </a:solidFill>
+              </a:rPr>
+              <a:t>El Gobierno deja de fijar la tasa: la BADLAR nominal pasa de 32% a casi 60% en agosto.</a:t>
+            </a:r>
+            <a:endParaRPr lang="en-US" sz="1200" dirty="0"/>
+          </a:p>
+        </p:txBody>
+      </p:sp>
+      <p:sp>
+        <p:nvSpPr>
+          <p:cNvPr id="37" name="Shape 34"/>
+          <p:cNvSpPr/>
+          <p:nvPr/>
+        </p:nvSpPr>
+        <p:spPr>
+          <a:xfrm>
+            <a:off x="8275320" y="3895344"/>
+            <a:ext cx="274320" cy="274320"/>
+          </a:xfrm>
+          <a:prstGeom prst="ellipse">
+            <a:avLst/>
+          </a:prstGeom>
+          <a:solidFill>
+            <a:schemeClr val="tx1"/>
+          </a:solidFill>
+          <a:ln/>
+        </p:spPr>
+      </p:sp>
+      <p:sp>
+        <p:nvSpPr>
+          <p:cNvPr id="38" name="Text 35"/>
+          <p:cNvSpPr txBox="1"/>
+          <p:nvPr/>
+        </p:nvSpPr>
+        <p:spPr>
+          <a:xfrm>
+            <a:off x="8275320" y="3895344"/>
+            <a:ext cx="274320" cy="274320"/>
+          </a:xfrm>
+          <a:prstGeom prst="rect">
+            <a:avLst/>
+          </a:prstGeom>
+          <a:noFill/>
+          <a:ln/>
+        </p:spPr>
+        <p:txBody>
+          <a:bodyPr wrap="square" lIns="0" tIns="0" rIns="0" bIns="0" rtlCol="0" anchor="ctr"/>
+          <a:lstStyle/>
+          <a:p>
+            <a:pPr algn="ctr" indent="0" marL="0">
+              <a:buNone/>
+            </a:pPr>
+            <a:r>
+              <a:rPr lang="en-US" sz="1100" b="1" dirty="0">
+                <a:solidFill>
+                  <a:schemeClr val="bg1"/>
+                </a:solidFill>
+              </a:rPr>
+              <a:t>3</a:t>
+            </a:r>
+            <a:endParaRPr lang="en-US" sz="1100" dirty="0"/>
+          </a:p>
+        </p:txBody>
+      </p:sp>
+      <p:sp>
+        <p:nvSpPr>
+          <p:cNvPr id="39" name="Text 36"/>
+          <p:cNvSpPr txBox="1"/>
+          <p:nvPr/>
+        </p:nvSpPr>
+        <p:spPr>
+          <a:xfrm>
+            <a:off x="8686800" y="3877056"/>
+            <a:ext cx="2727655" cy="896112"/>
+          </a:xfrm>
+          <a:prstGeom prst="rect">
+            <a:avLst/>
+          </a:prstGeom>
+          <a:noFill/>
+          <a:ln/>
+        </p:spPr>
+        <p:txBody>
+          <a:bodyPr wrap="square" lIns="0" tIns="0" rIns="0" bIns="0" rtlCol="0" anchor="t"/>
+          <a:lstStyle/>
+          <a:p>
+            <a:pPr indent="0" marL="0">
+              <a:spcAft>
+                <a:spcPts val="200"/>
+              </a:spcAft>
+              <a:buNone/>
+            </a:pPr>
+            <a:r>
+              <a:rPr lang="en-US" sz="1200" b="1" dirty="0">
+                <a:solidFill>
+                  <a:schemeClr val="tx1"/>
+                </a:solidFill>
+              </a:rPr>
+              <a:t>Sep-25 · Elecciones bonaerenses</a:t>
+            </a:r>
+            <a:endParaRPr lang="en-US" sz="1200" dirty="0"/>
+          </a:p>
+          <a:p>
+            <a:pPr indent="0" marL="0">
+              <a:spcAft>
+                <a:spcPts val="200"/>
+              </a:spcAft>
+              <a:buNone/>
+            </a:pPr>
+            <a:r>
+              <a:rPr lang="en-US" sz="1200" dirty="0">
+                <a:solidFill>
+                  <a:schemeClr val="tx1"/>
+                </a:solidFill>
+              </a:rPr>
+              <a:t>La incertidumbre electoral lleva la tasa real a casi 40% anual.</a:t>
+            </a:r>
+            <a:endParaRPr lang="en-US" sz="1200" dirty="0"/>
+          </a:p>
+        </p:txBody>
+      </p:sp>
+      <p:sp>
+        <p:nvSpPr>
+          <p:cNvPr id="40" name="Shape 37"/>
+          <p:cNvSpPr/>
+          <p:nvPr/>
+        </p:nvSpPr>
+        <p:spPr>
+          <a:xfrm>
+            <a:off x="8275320" y="4882896"/>
+            <a:ext cx="274320" cy="274320"/>
+          </a:xfrm>
+          <a:prstGeom prst="ellipse">
+            <a:avLst/>
+          </a:prstGeom>
+          <a:solidFill>
+            <a:schemeClr val="tx1"/>
+          </a:solidFill>
+          <a:ln/>
+        </p:spPr>
+      </p:sp>
+      <p:sp>
+        <p:nvSpPr>
+          <p:cNvPr id="41" name="Text 38"/>
+          <p:cNvSpPr txBox="1"/>
+          <p:nvPr/>
+        </p:nvSpPr>
+        <p:spPr>
+          <a:xfrm>
+            <a:off x="8275320" y="4882896"/>
+            <a:ext cx="274320" cy="274320"/>
+          </a:xfrm>
+          <a:prstGeom prst="rect">
+            <a:avLst/>
+          </a:prstGeom>
+          <a:noFill/>
+          <a:ln/>
+        </p:spPr>
+        <p:txBody>
+          <a:bodyPr wrap="square" lIns="0" tIns="0" rIns="0" bIns="0" rtlCol="0" anchor="ctr"/>
+          <a:lstStyle/>
+          <a:p>
+            <a:pPr algn="ctr" indent="0" marL="0">
+              <a:buNone/>
+            </a:pPr>
+            <a:r>
+              <a:rPr lang="en-US" sz="1100" b="1" dirty="0">
+                <a:solidFill>
+                  <a:schemeClr val="bg1"/>
+                </a:solidFill>
+              </a:rPr>
+              <a:t>4</a:t>
+            </a:r>
+            <a:endParaRPr lang="en-US" sz="1100" dirty="0"/>
+          </a:p>
+        </p:txBody>
+      </p:sp>
+      <p:sp>
+        <p:nvSpPr>
+          <p:cNvPr id="42" name="Text 39"/>
+          <p:cNvSpPr txBox="1"/>
+          <p:nvPr/>
+        </p:nvSpPr>
+        <p:spPr>
+          <a:xfrm>
+            <a:off x="8686800" y="4864608"/>
+            <a:ext cx="2727655" cy="896112"/>
+          </a:xfrm>
+          <a:prstGeom prst="rect">
+            <a:avLst/>
+          </a:prstGeom>
+          <a:noFill/>
+          <a:ln/>
+        </p:spPr>
+        <p:txBody>
+          <a:bodyPr wrap="square" lIns="0" tIns="0" rIns="0" bIns="0" rtlCol="0" anchor="t"/>
+          <a:lstStyle/>
+          <a:p>
+            <a:pPr indent="0" marL="0">
+              <a:spcAft>
+                <a:spcPts val="200"/>
+              </a:spcAft>
+              <a:buNone/>
+            </a:pPr>
+            <a:r>
+              <a:rPr lang="en-US" sz="1200" b="1" dirty="0">
+                <a:solidFill>
+                  <a:schemeClr val="tx1"/>
+                </a:solidFill>
+              </a:rPr>
+              <a:t>Oct-25 · Swap con EE.UU. y legislativas</a:t>
+            </a:r>
+            <a:endParaRPr lang="en-US" sz="1200" dirty="0"/>
+          </a:p>
+          <a:p>
+            <a:pPr indent="0" marL="0">
+              <a:spcAft>
+                <a:spcPts val="200"/>
+              </a:spcAft>
+              <a:buNone/>
+            </a:pPr>
+            <a:r>
+              <a:rPr lang="en-US" sz="1200" dirty="0">
+                <a:solidFill>
+                  <a:schemeClr val="tx1"/>
+                </a:solidFill>
+              </a:rPr>
+              <a:t>Tras el 20 y el 26 de octubre, las tasas bajan.</a:t>
+            </a:r>
+            <a:endParaRPr lang="en-US" sz="1200" dirty="0"/>
+          </a:p>
+        </p:txBody>
+      </p:sp>
+      <p:sp>
+        <p:nvSpPr>
+          <p:cNvPr id="43" name="Fuente"/>
           <p:cNvSpPr txBox="1"/>
           <p:nvPr/>
         </p:nvSpPr>
@@ -8041,7 +8872,7 @@
                   <a:schemeClr val="tx2"/>
                 </a:solidFill>
               </a:rPr>
-              <a:t>Fuente: BCRA (BADLAR bancos privados) e INDEC. Sombreado: período entre el fin de las LEFIs y el swap con EE.UU.</a:t>
+              <a:t>Fuente: BCRA (BADLAR bancos privados) e INDEC. Sombreado: tasas altas, entre el fin de las LEFIs y las elecciones legislativas.</a:t>
             </a:r>
             <a:endParaRPr lang="en-US" sz="1000" dirty="0"/>
           </a:p>

</xml_diff>

<commit_message>
Presentación: ajustar espaciado de los hitos en la diapositiva de tasas
Co-Authored-By: Claude Opus 5.5 <noreply@anthropic.com>
Claude-Session: https://claude.ai/code/session_01LjZCUeZeukTqwmHG81QxgV
</commit_message>
<xml_diff>
--- a/presentaciones/crisis_fundar_mejorada.pptx
+++ b/presentaciones/crisis_fundar_mejorada.pptx
@@ -114,29 +114,29 @@
   <p:extLst>
     <p:ext uri="{521415D9-36F7-43E2-AB2F-B90AF26B5E84}">
       <p14:sectionLst xmlns:p14="http://schemas.microsoft.com/office/powerpoint/2010/main">
-        <p14:section name="Portada" id="{f4540468-2e92-7f6d-c0c6-b270b9cc4590}">
+        <p14:section name="Portada" id="{d10bdee5-387f-d5e9-fec9-08d3f4719f7d}">
           <p14:sldIdLst>
             <p14:sldId id="256"/>
           </p14:sldIdLst>
         </p14:section>
-        <p14:section name="Resumen" id="{eb210b88-5c41-1ef1-102b-18eb37e10fc4}">
+        <p14:section name="Resumen" id="{2d9dc4d0-43c8-6222-f055-c6a0737fc662}">
           <p14:sldIdLst>
             <p14:sldId id="257"/>
           </p14:sldIdLst>
         </p14:section>
-        <p14:section name="Diagnóstico" id="{4d8a5886-758f-d8e9-4364-ca4cecc0cadc}">
+        <p14:section name="Diagnóstico" id="{5f71bada-9ac6-e08b-9fb0-911eb847c0be}">
           <p14:sldIdLst>
             <p14:sldId id="258"/>
             <p14:sldId id="259"/>
             <p14:sldId id="260"/>
           </p14:sldIdLst>
         </p14:section>
-        <p14:section name="Mora" id="{21dc7088-b180-cba9-647c-8b38dc56d9ff}">
+        <p14:section name="Mora" id="{8b630a23-5ba0-5530-e758-737e3f444501}">
           <p14:sldIdLst>
             <p14:sldId id="261"/>
           </p14:sldIdLst>
         </p14:section>
-        <p14:section name="Propuestas" id="{8f4d3d8c-9c1b-0821-a625-bca0cade4fdc}">
+        <p14:section name="Propuestas" id="{86a28107-fc4f-3c69-fe1c-8bf077560c74}">
           <p14:sldIdLst>
             <p14:sldId id="262"/>
             <p14:sldId id="263"/>
@@ -8402,7 +8402,7 @@
         </p:nvSpPr>
         <p:spPr>
           <a:xfrm>
-            <a:off x="8275320" y="1920240"/>
+            <a:off x="8275320" y="1874520"/>
             <a:ext cx="274320" cy="274320"/>
           </a:xfrm>
           <a:prstGeom prst="ellipse">
@@ -8422,7 +8422,7 @@
         </p:nvSpPr>
         <p:spPr>
           <a:xfrm>
-            <a:off x="8275320" y="1920240"/>
+            <a:off x="8275320" y="1874520"/>
             <a:ext cx="274320" cy="274320"/>
           </a:xfrm>
           <a:prstGeom prst="rect">
@@ -8458,7 +8458,7 @@
         </p:nvSpPr>
         <p:spPr>
           <a:xfrm>
-            <a:off x="8686800" y="1901952"/>
+            <a:off x="8686800" y="1856232"/>
             <a:ext cx="2727655" cy="896112"/>
           </a:xfrm>
           <a:prstGeom prst="rect">
@@ -8626,7 +8626,7 @@
         </p:nvSpPr>
         <p:spPr>
           <a:xfrm>
-            <a:off x="8275320" y="3895344"/>
+            <a:off x="8275320" y="3941064"/>
             <a:ext cx="274320" cy="274320"/>
           </a:xfrm>
           <a:prstGeom prst="ellipse">
@@ -8646,7 +8646,7 @@
         </p:nvSpPr>
         <p:spPr>
           <a:xfrm>
-            <a:off x="8275320" y="3895344"/>
+            <a:off x="8275320" y="3941064"/>
             <a:ext cx="274320" cy="274320"/>
           </a:xfrm>
           <a:prstGeom prst="rect">
@@ -8682,7 +8682,7 @@
         </p:nvSpPr>
         <p:spPr>
           <a:xfrm>
-            <a:off x="8686800" y="3877056"/>
+            <a:off x="8686800" y="3922776"/>
             <a:ext cx="2727655" cy="896112"/>
           </a:xfrm>
           <a:prstGeom prst="rect">
@@ -8738,7 +8738,7 @@
         </p:nvSpPr>
         <p:spPr>
           <a:xfrm>
-            <a:off x="8275320" y="4882896"/>
+            <a:off x="8275320" y="4974336"/>
             <a:ext cx="274320" cy="274320"/>
           </a:xfrm>
           <a:prstGeom prst="ellipse">
@@ -8758,7 +8758,7 @@
         </p:nvSpPr>
         <p:spPr>
           <a:xfrm>
-            <a:off x="8275320" y="4882896"/>
+            <a:off x="8275320" y="4974336"/>
             <a:ext cx="274320" cy="274320"/>
           </a:xfrm>
           <a:prstGeom prst="rect">
@@ -8794,7 +8794,7 @@
         </p:nvSpPr>
         <p:spPr>
           <a:xfrm>
-            <a:off x="8686800" y="4864608"/>
+            <a:off x="8686800" y="4956048"/>
             <a:ext cx="2727655" cy="896112"/>
           </a:xfrm>
           <a:prstGeom prst="rect">

</xml_diff>